<commit_message>
checkpoint: 2026-09-25 videocapsulas textuales del plan para el revisor
</commit_message>
<xml_diff>
--- a/modulo-2/PF1821-agentes-low-code/produccion/videos/AE1-capsula.pptx
+++ b/modulo-2/PF1821-agentes-low-code/produccion/videos/AE1-capsula.pptx
@@ -18,6 +18,7 @@
     <p:sldId id="263" r:id="rId17"/>
     <p:sldId id="264" r:id="rId18"/>
     <p:sldId id="265" r:id="rId19"/>
+    <p:sldId id="266" r:id="rId20"/>
   </p:sldIdLst>
   <p:sldSz cx="12192000" cy="6858000"/>
   <p:notesSz cx="6858000" cy="9144000"/>
@@ -161,7 +162,7 @@
           <a:p>
             <a:r>
               <a:rPr lang="es-CL" dirty="0"/>
-              <a:t>Te doy la bienvenida a la cápsula 1 del módulo 2: ¿Qué conviene automatizar?. "Automatizar con sentido". El caso: Mercado Austral y sus pedidos copiados a mano.</a:t>
+              <a:t>Te doy la bienvenida a la cápsula 1 del módulo 2, Fundamentos de n8n y manipulación de datos: ¿Qué conviene automatizar?. "Automatizar con sentido". El caso: Mercado Austral y sus pedidos copiados a mano.</a:t>
             </a:r>
           </a:p>
         </p:txBody>
@@ -220,6 +221,65 @@
           <a:p>
             <a:r>
               <a:rPr lang="es-CL" dirty="0"/>
+              <a:t>n8n frente a otras plataformas. Ver el cuadro comparativo. Idea central: n8n puede instalarse en infraestructura propia, lo que da control sobre los datos.</a:t>
+            </a:r>
+          </a:p>
+        </p:txBody>
+      </p:sp>
+    </p:spTree>
+  </p:cSld>
+  <p:clrMapOvr>
+    <a:masterClrMapping/>
+  </p:clrMapOvr>
+</p:notes>
+</file>
+
+<file path=ppt/notesSlides/notesSlide11.xml><?xml version="1.0" encoding="utf-8"?>
+<p:notes xmlns:a="http://schemas.openxmlformats.org/drawingml/2006/main" xmlns:r="http://schemas.openxmlformats.org/officeDocument/2006/relationships" xmlns:p="http://schemas.openxmlformats.org/presentationml/2006/main">
+  <p:cSld>
+    <p:spTree>
+      <p:nvGrpSpPr>
+        <p:cNvPr id="1" name=""/>
+        <p:cNvGrpSpPr/>
+        <p:nvPr/>
+      </p:nvGrpSpPr>
+      <p:grpSpPr>
+        <a:xfrm>
+          <a:off x="0" y="0"/>
+          <a:ext cx="0" cy="0"/>
+          <a:chOff x="0" y="0"/>
+          <a:chExt cx="0" cy="0"/>
+        </a:xfrm>
+      </p:grpSpPr>
+      <p:sp>
+        <p:nvSpPr>
+          <p:cNvPr id="2" name="Imagen de diapositiva"/>
+          <p:cNvSpPr>
+            <a:spLocks noGrp="1" noRot="1" noChangeAspect="1"/>
+          </p:cNvSpPr>
+          <p:nvPr>
+            <p:ph type="sldImg"/>
+          </p:nvPr>
+        </p:nvSpPr>
+        <p:spPr/>
+      </p:sp>
+      <p:sp>
+        <p:nvSpPr>
+          <p:cNvPr id="3" name="Notas"/>
+          <p:cNvSpPr>
+            <a:spLocks noGrp="1"/>
+          </p:cNvSpPr>
+          <p:nvPr>
+            <p:ph type="body" idx="1"/>
+          </p:nvPr>
+        </p:nvSpPr>
+        <p:spPr/>
+        <p:txBody>
+          <a:bodyPr/>
+          <a:lstStyle/>
+          <a:p>
+            <a:r>
+              <a:rPr lang="es-CL" dirty="0"/>
               <a:t>Tu tarea. Mapa de Mercado Austral: tres procesos que conviene automatizar y qué gana la empresa con cada uno. Va a tu portafolio (sección 1).</a:t>
             </a:r>
           </a:p>
@@ -279,7 +339,7 @@
           <a:p>
             <a:r>
               <a:rPr lang="es-CL" dirty="0"/>
-              <a:t>Qué es un workflow. Una secuencia de pasos que se ejecuta sola cuando ocurre algo: disparador, luego pasos, luego resultado. Ejemplo: llega un pedido, luego se valida, luego se guarda, luego se avisa.</a:t>
+              <a:t>Esta cápsula corresponde al aprendizaje esperado 1 del plan formativo: Distinguir los conceptos fundamentales de automatización de workflows y las características de n8n, de acuerdo con casos de uso empresariales reales. Sus criterios de evaluación son: Identifica aplicaciones donde la automatización de workflows aporta valor en contextos empresariales. Describe la arquitectura y los componentes principales de n8n con precisión técnica. Distingue las ventajas de n8n frente a otras herramientas de automatización.</a:t>
             </a:r>
           </a:p>
         </p:txBody>
@@ -338,7 +398,7 @@
           <a:p>
             <a:r>
               <a:rPr lang="es-CL" dirty="0"/>
-              <a:t>Qué conviene automatizar. Tareas repetitivas, de alto volumen, con reglas claras y datos digitales. Lo que no conviene: decisiones de criterio, tareas que ocurren una vez al año, procesos que todavía no están definidos.</a:t>
+              <a:t>Qué es un workflow. Una secuencia de pasos que se ejecuta sola cuando ocurre algo: disparador, luego pasos, luego resultado. Ejemplo: llega un pedido, luego se valida, luego se guarda, luego se avisa.</a:t>
             </a:r>
           </a:p>
         </p:txBody>
@@ -397,7 +457,7 @@
           <a:p>
             <a:r>
               <a:rPr lang="es-CL" dirty="0"/>
-              <a:t>Casos de uso empresariales. Registro de pedidos y formularios; avisos y notificaciones; sincronizar planillas, CRM y bases de datos; reportes periódicos; clasificación de solicitudes; incorporación de clientes.</a:t>
+              <a:t>Qué conviene automatizar. Tareas repetitivas, de alto volumen, con reglas claras y datos digitales. Lo que no conviene: decisiones de criterio, tareas que ocurren una vez al año, procesos que todavía no están definidos.</a:t>
             </a:r>
           </a:p>
         </p:txBody>
@@ -456,7 +516,7 @@
           <a:p>
             <a:r>
               <a:rPr lang="es-CL" dirty="0"/>
-              <a:t>Beneficios y retorno. Menos digitación y errores, respuesta inmediata, datos disponibles para decidir. Cálculo simple: 40 pedidos al día por 3 minutos es 2 h diarias, aproximadamente 40 h al mes que se liberan. Retorno es valor de las horas liberadas − costo de la herramienta.</a:t>
+              <a:t>Casos de uso empresariales. Registro de pedidos y formularios; avisos y notificaciones; sincronizar planillas, CRM y bases de datos; reportes periódicos; clasificación de solicitudes; incorporación de clientes.</a:t>
             </a:r>
           </a:p>
         </p:txBody>
@@ -515,7 +575,7 @@
           <a:p>
             <a:r>
               <a:rPr lang="es-CL" dirty="0"/>
-              <a:t>Arquitectura de n8n. Workflow (el flujo completo), nodos (cada paso: trigger, acción, lógica, transformación), conexiones, credenciales (acceso seguro a otros servicios), ejecuciones (cada vez que corre, con sus datos). Los datos viajan como ítems en formato JSON.</a:t>
+              <a:t>Beneficios y retorno. Menos digitación y errores, respuesta inmediata, datos disponibles para decidir. Cálculo simple: 40 pedidos al día por 3 minutos es 2 h diarias, aproximadamente 40 h al mes que se liberan. Retorno es valor de las horas liberadas − costo de la herramienta.</a:t>
             </a:r>
           </a:p>
         </p:txBody>
@@ -574,7 +634,7 @@
           <a:p>
             <a:r>
               <a:rPr lang="es-CL" dirty="0"/>
-              <a:t>Componentes de la interfaz. Canvas, panel de nodos, parámetros del nodo, paneles de entrada y salida, historial de ejecuciones.</a:t>
+              <a:t>Arquitectura de n8n. Workflow (el flujo completo), nodos (cada paso: trigger, acción, lógica, transformación), conexiones, credenciales (acceso seguro a otros servicios), ejecuciones (cada vez que corre, con sus datos). Los datos viajan como ítems en formato JSON.</a:t>
             </a:r>
           </a:p>
         </p:txBody>
@@ -633,7 +693,7 @@
           <a:p>
             <a:r>
               <a:rPr lang="es-CL" dirty="0"/>
-              <a:t>Ecosistema de nodos. Nodos nativos para cientos de servicios (bases de datos, correo, planillas, mensajería), HTTP Request para cualquier API, Code para lógica propia, nodos de IA (se ven en el módulo 5 del plan) y nodos de la comunidad.</a:t>
+              <a:t>Componentes de la interfaz. Canvas, panel de nodos, parámetros del nodo, paneles de entrada y salida, historial de ejecuciones.</a:t>
             </a:r>
           </a:p>
         </p:txBody>
@@ -692,7 +752,7 @@
           <a:p>
             <a:r>
               <a:rPr lang="es-CL" dirty="0"/>
-              <a:t>n8n frente a otras plataformas. Ver el cuadro comparativo. Idea central: n8n puede instalarse en infraestructura propia, lo que da control sobre los datos.</a:t>
+              <a:t>Ecosistema de nodos. Nodos nativos para cientos de servicios (bases de datos, correo, planillas, mensajería), HTTP Request para cualquier API, Code para lógica propia, nodos de IA (se ven en el módulo 5 del plan) y nodos de la comunidad.</a:t>
             </a:r>
           </a:p>
         </p:txBody>
@@ -841,6 +901,39 @@
       </p:sp>
       <p:sp>
         <p:nvSpPr>
+          <p:cNvPr id="7" name="Etiqueta"/>
+          <p:cNvSpPr txBox="1"/>
+          <p:nvPr/>
+        </p:nvSpPr>
+        <p:spPr>
+          <a:xfrm>
+            <a:off x="609600" y="609600"/>
+            <a:ext cx="7315200" cy="533400"/>
+          </a:xfrm>
+          <a:prstGeom prst="rect">
+            <a:avLst/>
+          </a:prstGeom>
+          <a:noFill/>
+        </p:spPr>
+        <p:txBody>
+          <a:bodyPr wrap="square" lIns="0" rIns="0" anchor="b">
+            <a:normAutofit/>
+          </a:bodyPr>
+          <a:lstStyle/>
+          <a:p>
+            <a:r>
+              <a:rPr lang="es-CL" sz="1200" b="1" dirty="0">
+                <a:solidFill>
+                  <a:srgbClr val="9FC3E6"/>
+                </a:solidFill>
+              </a:rPr>
+              <a:t>MÓDULO 2 · FUNDAMENTOS DE N8N Y MANIPULACIÓN DE DATOS</a:t>
+            </a:r>
+          </a:p>
+        </p:txBody>
+      </p:sp>
+      <p:sp>
+        <p:nvSpPr>
           <p:cNvPr id="4" name="Título"/>
           <p:cNvSpPr txBox="1"/>
           <p:nvPr/>
@@ -903,6 +996,16 @@
               <a:t>"Automatizar con sentido". El caso: Mercado Austral y sus pedidos copiados a mano.</a:t>
             </a:r>
           </a:p>
+          <a:p>
+            <a:r>
+              <a:rPr lang="es-CL" sz="2200" dirty="0">
+                <a:solidFill>
+                  <a:srgbClr val="E5E7EB"/>
+                </a:solidFill>
+              </a:rPr>
+              <a:t>Contenido del plan: 1. CONCEPTOS FUNDAMENTALES DE AUTOMATIZACIÓN DE WORKFLOWS Y LAS CARACTERÍSTICAS DE N8N</a:t>
+            </a:r>
+          </a:p>
         </p:txBody>
       </p:sp>
       <p:sp>
@@ -933,7 +1036,7 @@
                   <a:srgbClr val="CBD5E1"/>
                 </a:solidFill>
               </a:rPr>
-              <a:t>PF1821 · Módulo 2 · Cápsula 1 · AE1</a:t>
+              <a:t>PF1821 · Módulo 2 · Cápsula 1 · Aprendizaje esperado 1</a:t>
             </a:r>
           </a:p>
         </p:txBody>
@@ -987,14 +1090,57 @@
       </p:sp>
       <p:sp>
         <p:nvSpPr>
+          <p:cNvPr id="7" name="Etiqueta"/>
+          <p:cNvSpPr txBox="1"/>
+          <p:nvPr/>
+        </p:nvSpPr>
+        <p:spPr>
+          <a:xfrm>
+            <a:off x="609600" y="228600"/>
+            <a:ext cx="7315200" cy="914400"/>
+          </a:xfrm>
+          <a:prstGeom prst="rect">
+            <a:avLst/>
+          </a:prstGeom>
+          <a:noFill/>
+        </p:spPr>
+        <p:txBody>
+          <a:bodyPr wrap="square" lIns="0" rIns="0" anchor="b">
+            <a:normAutofit/>
+          </a:bodyPr>
+          <a:lstStyle/>
+          <a:p>
+            <a:r>
+              <a:rPr lang="es-CL" sz="1200" b="1" dirty="0">
+                <a:solidFill>
+                  <a:srgbClr val="0E7490"/>
+                </a:solidFill>
+              </a:rPr>
+              <a:t>CONTENIDO DEL PLAN (TEXTUAL)</a:t>
+            </a:r>
+          </a:p>
+          <a:p>
+            <a:r>
+              <a:rPr lang="es-CL" sz="1200" b="1" dirty="0">
+                <a:solidFill>
+                  <a:srgbClr val="0F3D5E"/>
+                </a:solidFill>
+              </a:rPr>
+              <a:t>DIFERENCIAS CON OTRAS PLATAFORMAS DE AUTOMATIZACIÓN.</a:t>
+            </a:r>
+          </a:p>
+        </p:txBody>
+      </p:sp>
+      <p:sp>
+        <p:nvSpPr>
           <p:cNvPr id="3" name="Título"/>
           <p:cNvSpPr txBox="1"/>
           <p:nvPr/>
         </p:nvSpPr>
         <p:spPr>
           <a:xfrm>
-            <a:off x="609600" y="381000"/>
-            <a:ext cx="7315200" cy="990600"/>
+            <a:off x="609600" y="1181100"/>
+            <a:ext cx="7315200" cy="685800"/>
           </a:xfrm>
           <a:prstGeom prst="rect">
             <a:avLst/>
@@ -1008,12 +1154,12 @@
           <a:lstStyle/>
           <a:p>
             <a:r>
-              <a:rPr lang="es-CL" sz="3200" b="1" dirty="0">
+              <a:rPr lang="es-CL" sz="2800" b="1" dirty="0">
                 <a:solidFill>
                   <a:srgbClr val="0F3D5E"/>
                 </a:solidFill>
               </a:rPr>
-              <a:t>Tu tarea</a:t>
+              <a:t>n8n frente a otras plataformas</a:t>
             </a:r>
           </a:p>
         </p:txBody>
@@ -1026,7 +1172,7 @@
         </p:nvSpPr>
         <p:spPr>
           <a:xfrm>
-            <a:off x="609600" y="1447800"/>
+            <a:off x="609600" y="1943100"/>
             <a:ext cx="1066800" cy="50800"/>
           </a:xfrm>
           <a:prstGeom prst="rect">
@@ -1048,8 +1194,8 @@
         </p:nvSpPr>
         <p:spPr>
           <a:xfrm>
-            <a:off x="609600" y="1676400"/>
-            <a:ext cx="7315200" cy="4419600"/>
+            <a:off x="609600" y="2095500"/>
+            <a:ext cx="7315200" cy="4000500"/>
           </a:xfrm>
           <a:prstGeom prst="rect">
             <a:avLst/>
@@ -1078,7 +1224,7 @@
                   <a:srgbClr val="1F2937"/>
                 </a:solidFill>
               </a:rPr>
-              <a:t>Mapa de Mercado Austral: tres procesos que conviene automatizar y qué gana la empresa con cada uno.</a:t>
+              <a:t>Ver el cuadro comparativo R04.</a:t>
             </a:r>
           </a:p>
           <a:p>
@@ -1098,7 +1244,7 @@
                   <a:srgbClr val="1F2937"/>
                 </a:solidFill>
               </a:rPr>
-              <a:t>Va a tu portafolio (sección 1).</a:t>
+              <a:t>Idea central: n8n puede instalarse en infraestructura propia, lo que da control sobre los datos.</a:t>
             </a:r>
           </a:p>
         </p:txBody>
@@ -1131,7 +1277,238 @@
                   <a:srgbClr val="6B7280"/>
                 </a:solidFill>
               </a:rPr>
-              <a:t>PF1821 · Módulo 2 · Cápsula 1 · AE1</a:t>
+              <a:t>PF1821 · Módulo 2 · Cápsula 1 · Aprendizaje esperado 1</a:t>
+            </a:r>
+          </a:p>
+        </p:txBody>
+      </p:sp>
+    </p:spTree>
+  </p:cSld>
+  <p:clrMapOvr>
+    <a:masterClrMapping/>
+  </p:clrMapOvr>
+</p:sld>
+</file>
+
+<file path=ppt/slides/slide11.xml><?xml version="1.0" encoding="utf-8"?>
+<p:sld xmlns:a="http://schemas.openxmlformats.org/drawingml/2006/main" xmlns:r="http://schemas.openxmlformats.org/officeDocument/2006/relationships" xmlns:p="http://schemas.openxmlformats.org/presentationml/2006/main">
+  <p:cSld>
+    <p:spTree>
+      <p:nvGrpSpPr>
+        <p:cNvPr id="1" name=""/>
+        <p:cNvGrpSpPr/>
+        <p:nvPr/>
+      </p:nvGrpSpPr>
+      <p:grpSpPr>
+        <a:xfrm>
+          <a:off x="0" y="0"/>
+          <a:ext cx="0" cy="0"/>
+          <a:chOff x="0" y="0"/>
+          <a:chExt cx="0" cy="0"/>
+        </a:xfrm>
+      </p:grpSpPr>
+      <p:sp>
+        <p:nvSpPr>
+          <p:cNvPr id="2" name="Franja 2"/>
+          <p:cNvSpPr/>
+          <p:nvPr/>
+        </p:nvSpPr>
+        <p:spPr>
+          <a:xfrm>
+            <a:off x="0" y="0"/>
+            <a:ext cx="12192000" cy="152400"/>
+          </a:xfrm>
+          <a:prstGeom prst="rect">
+            <a:avLst/>
+          </a:prstGeom>
+          <a:solidFill>
+            <a:srgbClr val="0E7490"/>
+          </a:solidFill>
+          <a:ln>
+            <a:noFill/>
+          </a:ln>
+        </p:spPr>
+      </p:sp>
+      <p:sp>
+        <p:nvSpPr>
+          <p:cNvPr id="7" name="Etiqueta"/>
+          <p:cNvSpPr txBox="1"/>
+          <p:nvPr/>
+        </p:nvSpPr>
+        <p:spPr>
+          <a:xfrm>
+            <a:off x="609600" y="228600"/>
+            <a:ext cx="7315200" cy="914400"/>
+          </a:xfrm>
+          <a:prstGeom prst="rect">
+            <a:avLst/>
+          </a:prstGeom>
+          <a:noFill/>
+        </p:spPr>
+        <p:txBody>
+          <a:bodyPr wrap="square" lIns="0" rIns="0" anchor="b">
+            <a:normAutofit/>
+          </a:bodyPr>
+          <a:lstStyle/>
+          <a:p>
+            <a:r>
+              <a:rPr lang="es-CL" sz="1200" b="1" dirty="0">
+                <a:solidFill>
+                  <a:srgbClr val="0E7490"/>
+                </a:solidFill>
+              </a:rPr>
+              <a:t>PRÁCTICA DEL APRENDIZAJE ESPERADO 1</a:t>
+            </a:r>
+          </a:p>
+        </p:txBody>
+      </p:sp>
+      <p:sp>
+        <p:nvSpPr>
+          <p:cNvPr id="3" name="Título"/>
+          <p:cNvSpPr txBox="1"/>
+          <p:nvPr/>
+        </p:nvSpPr>
+        <p:spPr>
+          <a:xfrm>
+            <a:off x="609600" y="1181100"/>
+            <a:ext cx="7315200" cy="685800"/>
+          </a:xfrm>
+          <a:prstGeom prst="rect">
+            <a:avLst/>
+          </a:prstGeom>
+          <a:noFill/>
+        </p:spPr>
+        <p:txBody>
+          <a:bodyPr wrap="square" lIns="0" rIns="0" anchor="b">
+            <a:normAutofit/>
+          </a:bodyPr>
+          <a:lstStyle/>
+          <a:p>
+            <a:r>
+              <a:rPr lang="es-CL" sz="2800" b="1" dirty="0">
+                <a:solidFill>
+                  <a:srgbClr val="0F3D5E"/>
+                </a:solidFill>
+              </a:rPr>
+              <a:t>Tu tarea</a:t>
+            </a:r>
+          </a:p>
+        </p:txBody>
+      </p:sp>
+      <p:sp>
+        <p:nvSpPr>
+          <p:cNvPr id="4" name="Franja 4"/>
+          <p:cNvSpPr/>
+          <p:nvPr/>
+        </p:nvSpPr>
+        <p:spPr>
+          <a:xfrm>
+            <a:off x="609600" y="1943100"/>
+            <a:ext cx="1066800" cy="50800"/>
+          </a:xfrm>
+          <a:prstGeom prst="rect">
+            <a:avLst/>
+          </a:prstGeom>
+          <a:solidFill>
+            <a:srgbClr val="F59E0B"/>
+          </a:solidFill>
+          <a:ln>
+            <a:noFill/>
+          </a:ln>
+        </p:spPr>
+      </p:sp>
+      <p:sp>
+        <p:nvSpPr>
+          <p:cNvPr id="5" name="Contenido"/>
+          <p:cNvSpPr txBox="1"/>
+          <p:nvPr/>
+        </p:nvSpPr>
+        <p:spPr>
+          <a:xfrm>
+            <a:off x="609600" y="2095500"/>
+            <a:ext cx="7315200" cy="4000500"/>
+          </a:xfrm>
+          <a:prstGeom prst="rect">
+            <a:avLst/>
+          </a:prstGeom>
+          <a:noFill/>
+        </p:spPr>
+        <p:txBody>
+          <a:bodyPr wrap="square" lIns="0" rIns="0" anchor="t">
+            <a:normAutofit/>
+          </a:bodyPr>
+          <a:lstStyle/>
+          <a:p>
+            <a:pPr marL="342900" indent="-342900">
+              <a:spcBef>
+                <a:spcPts val="900"/>
+              </a:spcBef>
+              <a:buClr>
+                <a:srgbClr val="0E7490"/>
+              </a:buClr>
+              <a:buFont typeface="Arial"/>
+              <a:buChar char="•"/>
+            </a:pPr>
+            <a:r>
+              <a:rPr lang="es-CL" sz="2400" dirty="0">
+                <a:solidFill>
+                  <a:srgbClr val="1F2937"/>
+                </a:solidFill>
+              </a:rPr>
+              <a:t>Mapa de Mercado Austral: tres procesos que conviene automatizar y qué gana la empresa con cada uno.</a:t>
+            </a:r>
+          </a:p>
+          <a:p>
+            <a:pPr marL="342900" indent="-342900">
+              <a:spcBef>
+                <a:spcPts val="900"/>
+              </a:spcBef>
+              <a:buClr>
+                <a:srgbClr val="0E7490"/>
+              </a:buClr>
+              <a:buFont typeface="Arial"/>
+              <a:buChar char="•"/>
+            </a:pPr>
+            <a:r>
+              <a:rPr lang="es-CL" sz="2400" dirty="0">
+                <a:solidFill>
+                  <a:srgbClr val="1F2937"/>
+                </a:solidFill>
+              </a:rPr>
+              <a:t>Va a tu portafolio (sección 1).</a:t>
+            </a:r>
+          </a:p>
+        </p:txBody>
+      </p:sp>
+      <p:sp>
+        <p:nvSpPr>
+          <p:cNvPr id="6" name="Pie"/>
+          <p:cNvSpPr txBox="1"/>
+          <p:nvPr/>
+        </p:nvSpPr>
+        <p:spPr>
+          <a:xfrm>
+            <a:off x="609600" y="6248400"/>
+            <a:ext cx="7315200" cy="381000"/>
+          </a:xfrm>
+          <a:prstGeom prst="rect">
+            <a:avLst/>
+          </a:prstGeom>
+          <a:noFill/>
+        </p:spPr>
+        <p:txBody>
+          <a:bodyPr wrap="square" lIns="0" rIns="0" anchor="t">
+            <a:normAutofit/>
+          </a:bodyPr>
+          <a:lstStyle/>
+          <a:p>
+            <a:r>
+              <a:rPr lang="es-CL" sz="1200" dirty="0">
+                <a:solidFill>
+                  <a:srgbClr val="6B7280"/>
+                </a:solidFill>
+              </a:rPr>
+              <a:t>PF1821 · Módulo 2 · Cápsula 1 · Aprendizaje esperado 1</a:t>
             </a:r>
           </a:p>
         </p:txBody>
@@ -1185,14 +1562,47 @@
       </p:sp>
       <p:sp>
         <p:nvSpPr>
+          <p:cNvPr id="7" name="Etiqueta"/>
+          <p:cNvSpPr txBox="1"/>
+          <p:nvPr/>
+        </p:nvSpPr>
+        <p:spPr>
+          <a:xfrm>
+            <a:off x="609600" y="228600"/>
+            <a:ext cx="7315200" cy="914400"/>
+          </a:xfrm>
+          <a:prstGeom prst="rect">
+            <a:avLst/>
+          </a:prstGeom>
+          <a:noFill/>
+        </p:spPr>
+        <p:txBody>
+          <a:bodyPr wrap="square" lIns="0" rIns="0" anchor="b">
+            <a:normAutofit/>
+          </a:bodyPr>
+          <a:lstStyle/>
+          <a:p>
+            <a:r>
+              <a:rPr lang="es-CL" sz="1200" b="1" dirty="0">
+                <a:solidFill>
+                  <a:srgbClr val="0E7490"/>
+                </a:solidFill>
+              </a:rPr>
+              <a:t>APRENDIZAJE Y CRITERIOS TEXTUALES DEL PLAN FORMATIVO</a:t>
+            </a:r>
+          </a:p>
+        </p:txBody>
+      </p:sp>
+      <p:sp>
+        <p:nvSpPr>
           <p:cNvPr id="3" name="Título"/>
           <p:cNvSpPr txBox="1"/>
           <p:nvPr/>
         </p:nvSpPr>
         <p:spPr>
           <a:xfrm>
-            <a:off x="609600" y="381000"/>
-            <a:ext cx="7315200" cy="990600"/>
+            <a:off x="609600" y="1181100"/>
+            <a:ext cx="7315200" cy="685800"/>
           </a:xfrm>
           <a:prstGeom prst="rect">
             <a:avLst/>
@@ -1206,12 +1616,12 @@
           <a:lstStyle/>
           <a:p>
             <a:r>
-              <a:rPr lang="es-CL" sz="3200" b="1" dirty="0">
+              <a:rPr lang="es-CL" sz="2800" b="1" dirty="0">
                 <a:solidFill>
                   <a:srgbClr val="0F3D5E"/>
                 </a:solidFill>
               </a:rPr>
-              <a:t>Qué es un workflow</a:t>
+              <a:t>Aprendizaje esperado 1</a:t>
             </a:r>
           </a:p>
         </p:txBody>
@@ -1224,7 +1634,7 @@
         </p:nvSpPr>
         <p:spPr>
           <a:xfrm>
-            <a:off x="609600" y="1447800"/>
+            <a:off x="609600" y="1943100"/>
             <a:ext cx="1066800" cy="50800"/>
           </a:xfrm>
           <a:prstGeom prst="rect">
@@ -1246,8 +1656,8 @@
         </p:nvSpPr>
         <p:spPr>
           <a:xfrm>
-            <a:off x="609600" y="1676400"/>
-            <a:ext cx="7315200" cy="4419600"/>
+            <a:off x="609600" y="2095500"/>
+            <a:ext cx="7315200" cy="4000500"/>
           </a:xfrm>
           <a:prstGeom prst="rect">
             <a:avLst/>
@@ -1271,28 +1681,28 @@
               <a:buChar char="•"/>
             </a:pPr>
             <a:r>
-              <a:rPr lang="es-CL" sz="2400" dirty="0">
-                <a:solidFill>
-                  <a:srgbClr val="1F2937"/>
-                </a:solidFill>
-              </a:rPr>
-              <a:t>Una secuencia de pasos que se ejecuta sola cuando ocurre algo: </a:t>
-            </a:r>
-            <a:r>
-              <a:rPr lang="es-CL" sz="2400" b="1" dirty="0">
-                <a:solidFill>
-                  <a:srgbClr val="1F2937"/>
-                </a:solidFill>
-              </a:rPr>
-              <a:t>disparador → pasos → resultado</a:t>
-            </a:r>
-            <a:r>
-              <a:rPr lang="es-CL" sz="2400" dirty="0">
-                <a:solidFill>
-                  <a:srgbClr val="1F2937"/>
-                </a:solidFill>
-              </a:rPr>
-              <a:t>.</a:t>
+              <a:rPr lang="es-CL" sz="1600" b="1" dirty="0">
+                <a:solidFill>
+                  <a:srgbClr val="1F2937"/>
+                </a:solidFill>
+              </a:rPr>
+              <a:t>DISTINGUIR LOS CONCEPTOS FUNDAMENTALES DE AUTOMATIZACIÓN DE WORKFLOWS Y LAS CARACTERÍSTICAS DE N8N, DE ACUERDO CON CASOS DE USO EMPRESARIALES REALES.</a:t>
+            </a:r>
+          </a:p>
+          <a:p>
+            <a:pPr marL="0" indent="0">
+              <a:spcBef>
+                <a:spcPts val="1400"/>
+              </a:spcBef>
+              <a:buNone/>
+            </a:pPr>
+            <a:r>
+              <a:rPr lang="es-CL" sz="1400" b="1" dirty="0">
+                <a:solidFill>
+                  <a:srgbClr val="0E7490"/>
+                </a:solidFill>
+              </a:rPr>
+              <a:t>CRITERIOS DE EVALUACIÓN</a:t>
             </a:r>
           </a:p>
           <a:p>
@@ -1307,12 +1717,52 @@
               <a:buChar char="•"/>
             </a:pPr>
             <a:r>
-              <a:rPr lang="es-CL" sz="2400" dirty="0">
-                <a:solidFill>
-                  <a:srgbClr val="1F2937"/>
-                </a:solidFill>
-              </a:rPr>
-              <a:t>Ejemplo: llega un pedido → se valida → se guarda → se avisa.</a:t>
+              <a:rPr lang="es-CL" sz="1600" dirty="0">
+                <a:solidFill>
+                  <a:srgbClr val="1F2937"/>
+                </a:solidFill>
+              </a:rPr>
+              <a:t>1.1 IDENTIFICA APLICACIONES DONDE LA AUTOMATIZACIÓN DE WORKFLOWS APORTA VALOR EN CONTEXTOS EMPRESARIALES.</a:t>
+            </a:r>
+          </a:p>
+          <a:p>
+            <a:pPr marL="342900" indent="-342900">
+              <a:spcBef>
+                <a:spcPts val="900"/>
+              </a:spcBef>
+              <a:buClr>
+                <a:srgbClr val="0E7490"/>
+              </a:buClr>
+              <a:buFont typeface="Arial"/>
+              <a:buChar char="•"/>
+            </a:pPr>
+            <a:r>
+              <a:rPr lang="es-CL" sz="1600" dirty="0">
+                <a:solidFill>
+                  <a:srgbClr val="1F2937"/>
+                </a:solidFill>
+              </a:rPr>
+              <a:t>1.2 DESCRIBE LA ARQUITECTURA Y LOS COMPONENTES PRINCIPALES DE N8N CON PRECISIÓN TÉCNICA.</a:t>
+            </a:r>
+          </a:p>
+          <a:p>
+            <a:pPr marL="342900" indent="-342900">
+              <a:spcBef>
+                <a:spcPts val="900"/>
+              </a:spcBef>
+              <a:buClr>
+                <a:srgbClr val="0E7490"/>
+              </a:buClr>
+              <a:buFont typeface="Arial"/>
+              <a:buChar char="•"/>
+            </a:pPr>
+            <a:r>
+              <a:rPr lang="es-CL" sz="1600" dirty="0">
+                <a:solidFill>
+                  <a:srgbClr val="1F2937"/>
+                </a:solidFill>
+              </a:rPr>
+              <a:t>1.3 DISTINGUE LAS VENTAJAS DE N8N FRENTE A OTRAS HERRAMIENTAS DE AUTOMATIZACIÓN.</a:t>
             </a:r>
           </a:p>
         </p:txBody>
@@ -1345,7 +1795,7 @@
                   <a:srgbClr val="6B7280"/>
                 </a:solidFill>
               </a:rPr>
-              <a:t>PF1821 · Módulo 2 · Cápsula 1 · AE1</a:t>
+              <a:t>PF1821 · Módulo 2 · Cápsula 1 · Aprendizaje esperado 1</a:t>
             </a:r>
           </a:p>
         </p:txBody>
@@ -1399,14 +1849,57 @@
       </p:sp>
       <p:sp>
         <p:nvSpPr>
+          <p:cNvPr id="7" name="Etiqueta"/>
+          <p:cNvSpPr txBox="1"/>
+          <p:nvPr/>
+        </p:nvSpPr>
+        <p:spPr>
+          <a:xfrm>
+            <a:off x="609600" y="228600"/>
+            <a:ext cx="7315200" cy="914400"/>
+          </a:xfrm>
+          <a:prstGeom prst="rect">
+            <a:avLst/>
+          </a:prstGeom>
+          <a:noFill/>
+        </p:spPr>
+        <p:txBody>
+          <a:bodyPr wrap="square" lIns="0" rIns="0" anchor="b">
+            <a:normAutofit/>
+          </a:bodyPr>
+          <a:lstStyle/>
+          <a:p>
+            <a:r>
+              <a:rPr lang="es-CL" sz="1200" b="1" dirty="0">
+                <a:solidFill>
+                  <a:srgbClr val="0E7490"/>
+                </a:solidFill>
+              </a:rPr>
+              <a:t>CONTENIDO DEL PLAN (TEXTUAL)</a:t>
+            </a:r>
+          </a:p>
+          <a:p>
+            <a:r>
+              <a:rPr lang="es-CL" sz="1200" b="1" dirty="0">
+                <a:solidFill>
+                  <a:srgbClr val="0F3D5E"/>
+                </a:solidFill>
+              </a:rPr>
+              <a:t>CONCEPTOS FUNDAMENTALES DE WORKFLOW AUTOMATION.</a:t>
+            </a:r>
+          </a:p>
+        </p:txBody>
+      </p:sp>
+      <p:sp>
+        <p:nvSpPr>
           <p:cNvPr id="3" name="Título"/>
           <p:cNvSpPr txBox="1"/>
           <p:nvPr/>
         </p:nvSpPr>
         <p:spPr>
           <a:xfrm>
-            <a:off x="609600" y="381000"/>
-            <a:ext cx="7315200" cy="990600"/>
+            <a:off x="609600" y="1181100"/>
+            <a:ext cx="7315200" cy="685800"/>
           </a:xfrm>
           <a:prstGeom prst="rect">
             <a:avLst/>
@@ -1420,12 +1913,12 @@
           <a:lstStyle/>
           <a:p>
             <a:r>
-              <a:rPr lang="es-CL" sz="3200" b="1" dirty="0">
+              <a:rPr lang="es-CL" sz="2800" b="1" dirty="0">
                 <a:solidFill>
                   <a:srgbClr val="0F3D5E"/>
                 </a:solidFill>
               </a:rPr>
-              <a:t>Qué conviene automatizar</a:t>
+              <a:t>Qué es un workflow</a:t>
             </a:r>
           </a:p>
         </p:txBody>
@@ -1438,7 +1931,7 @@
         </p:nvSpPr>
         <p:spPr>
           <a:xfrm>
-            <a:off x="609600" y="1447800"/>
+            <a:off x="609600" y="1943100"/>
             <a:ext cx="1066800" cy="50800"/>
           </a:xfrm>
           <a:prstGeom prst="rect">
@@ -1460,8 +1953,8 @@
         </p:nvSpPr>
         <p:spPr>
           <a:xfrm>
-            <a:off x="609600" y="1676400"/>
-            <a:ext cx="7315200" cy="4419600"/>
+            <a:off x="609600" y="2095500"/>
+            <a:ext cx="7315200" cy="4000500"/>
           </a:xfrm>
           <a:prstGeom prst="rect">
             <a:avLst/>
@@ -1485,60 +1978,28 @@
               <a:buChar char="•"/>
             </a:pPr>
             <a:r>
-              <a:rPr lang="es-CL" sz="2000" dirty="0">
-                <a:solidFill>
-                  <a:srgbClr val="1F2937"/>
-                </a:solidFill>
-              </a:rPr>
-              <a:t>Tareas </a:t>
-            </a:r>
-            <a:r>
-              <a:rPr lang="es-CL" sz="2000" b="1" dirty="0">
-                <a:solidFill>
-                  <a:srgbClr val="1F2937"/>
-                </a:solidFill>
-              </a:rPr>
-              <a:t>repetitivas</a:t>
-            </a:r>
-            <a:r>
-              <a:rPr lang="es-CL" sz="2000" dirty="0">
-                <a:solidFill>
-                  <a:srgbClr val="1F2937"/>
-                </a:solidFill>
-              </a:rPr>
-              <a:t>, de </a:t>
-            </a:r>
-            <a:r>
-              <a:rPr lang="es-CL" sz="2000" b="1" dirty="0">
-                <a:solidFill>
-                  <a:srgbClr val="1F2937"/>
-                </a:solidFill>
-              </a:rPr>
-              <a:t>alto volumen</a:t>
-            </a:r>
-            <a:r>
-              <a:rPr lang="es-CL" sz="2000" dirty="0">
-                <a:solidFill>
-                  <a:srgbClr val="1F2937"/>
-                </a:solidFill>
-              </a:rPr>
-              <a:t>, con </a:t>
-            </a:r>
-            <a:r>
-              <a:rPr lang="es-CL" sz="2000" b="1" dirty="0">
-                <a:solidFill>
-                  <a:srgbClr val="1F2937"/>
-                </a:solidFill>
-              </a:rPr>
-              <a:t>reglas claras</a:t>
-            </a:r>
-            <a:r>
-              <a:rPr lang="es-CL" sz="2000" dirty="0">
-                <a:solidFill>
-                  <a:srgbClr val="1F2937"/>
-                </a:solidFill>
-              </a:rPr>
-              <a:t> y datos digitales.</a:t>
+              <a:rPr lang="es-CL" sz="2400" dirty="0">
+                <a:solidFill>
+                  <a:srgbClr val="1F2937"/>
+                </a:solidFill>
+              </a:rPr>
+              <a:t>Una secuencia de pasos que se ejecuta sola cuando ocurre algo: </a:t>
+            </a:r>
+            <a:r>
+              <a:rPr lang="es-CL" sz="2400" b="1" dirty="0">
+                <a:solidFill>
+                  <a:srgbClr val="1F2937"/>
+                </a:solidFill>
+              </a:rPr>
+              <a:t>disparador → pasos → resultado</a:t>
+            </a:r>
+            <a:r>
+              <a:rPr lang="es-CL" sz="2400" dirty="0">
+                <a:solidFill>
+                  <a:srgbClr val="1F2937"/>
+                </a:solidFill>
+              </a:rPr>
+              <a:t>.</a:t>
             </a:r>
           </a:p>
           <a:p>
@@ -1553,12 +2014,12 @@
               <a:buChar char="•"/>
             </a:pPr>
             <a:r>
-              <a:rPr lang="es-CL" sz="2000" dirty="0">
-                <a:solidFill>
-                  <a:srgbClr val="1F2937"/>
-                </a:solidFill>
-              </a:rPr>
-              <a:t>Lo que no conviene: decisiones de criterio, tareas que ocurren una vez al año, procesos que todavía no están definidos.</a:t>
+              <a:rPr lang="es-CL" sz="2400" dirty="0">
+                <a:solidFill>
+                  <a:srgbClr val="1F2937"/>
+                </a:solidFill>
+              </a:rPr>
+              <a:t>Ejemplo: llega un pedido → se valida → se guarda → se avisa.</a:t>
             </a:r>
           </a:p>
         </p:txBody>
@@ -1591,7 +2052,7 @@
                   <a:srgbClr val="6B7280"/>
                 </a:solidFill>
               </a:rPr>
-              <a:t>PF1821 · Módulo 2 · Cápsula 1 · AE1</a:t>
+              <a:t>PF1821 · Módulo 2 · Cápsula 1 · Aprendizaje esperado 1</a:t>
             </a:r>
           </a:p>
         </p:txBody>
@@ -1645,14 +2106,57 @@
       </p:sp>
       <p:sp>
         <p:nvSpPr>
+          <p:cNvPr id="7" name="Etiqueta"/>
+          <p:cNvSpPr txBox="1"/>
+          <p:nvPr/>
+        </p:nvSpPr>
+        <p:spPr>
+          <a:xfrm>
+            <a:off x="609600" y="228600"/>
+            <a:ext cx="7315200" cy="914400"/>
+          </a:xfrm>
+          <a:prstGeom prst="rect">
+            <a:avLst/>
+          </a:prstGeom>
+          <a:noFill/>
+        </p:spPr>
+        <p:txBody>
+          <a:bodyPr wrap="square" lIns="0" rIns="0" anchor="b">
+            <a:normAutofit/>
+          </a:bodyPr>
+          <a:lstStyle/>
+          <a:p>
+            <a:r>
+              <a:rPr lang="es-CL" sz="1200" b="1" dirty="0">
+                <a:solidFill>
+                  <a:srgbClr val="0E7490"/>
+                </a:solidFill>
+              </a:rPr>
+              <a:t>CONTENIDO DEL PLAN (TEXTUAL)</a:t>
+            </a:r>
+          </a:p>
+          <a:p>
+            <a:r>
+              <a:rPr lang="es-CL" sz="1200" b="1" dirty="0">
+                <a:solidFill>
+                  <a:srgbClr val="0F3D5E"/>
+                </a:solidFill>
+              </a:rPr>
+              <a:t>CONCEPTOS FUNDAMENTALES DE WORKFLOW AUTOMATION.</a:t>
+            </a:r>
+          </a:p>
+        </p:txBody>
+      </p:sp>
+      <p:sp>
+        <p:nvSpPr>
           <p:cNvPr id="3" name="Título"/>
           <p:cNvSpPr txBox="1"/>
           <p:nvPr/>
         </p:nvSpPr>
         <p:spPr>
           <a:xfrm>
-            <a:off x="609600" y="381000"/>
-            <a:ext cx="7315200" cy="990600"/>
+            <a:off x="609600" y="1181100"/>
+            <a:ext cx="7315200" cy="685800"/>
           </a:xfrm>
           <a:prstGeom prst="rect">
             <a:avLst/>
@@ -1666,12 +2170,12 @@
           <a:lstStyle/>
           <a:p>
             <a:r>
-              <a:rPr lang="es-CL" sz="3200" b="1" dirty="0">
+              <a:rPr lang="es-CL" sz="2800" b="1" dirty="0">
                 <a:solidFill>
                   <a:srgbClr val="0F3D5E"/>
                 </a:solidFill>
               </a:rPr>
-              <a:t>Casos de uso empresariales</a:t>
+              <a:t>Qué conviene automatizar</a:t>
             </a:r>
           </a:p>
         </p:txBody>
@@ -1684,7 +2188,7 @@
         </p:nvSpPr>
         <p:spPr>
           <a:xfrm>
-            <a:off x="609600" y="1447800"/>
+            <a:off x="609600" y="1943100"/>
             <a:ext cx="1066800" cy="50800"/>
           </a:xfrm>
           <a:prstGeom prst="rect">
@@ -1706,8 +2210,8 @@
         </p:nvSpPr>
         <p:spPr>
           <a:xfrm>
-            <a:off x="609600" y="1676400"/>
-            <a:ext cx="7315200" cy="4419600"/>
+            <a:off x="609600" y="2095500"/>
+            <a:ext cx="7315200" cy="4000500"/>
           </a:xfrm>
           <a:prstGeom prst="rect">
             <a:avLst/>
@@ -1731,12 +2235,80 @@
               <a:buChar char="•"/>
             </a:pPr>
             <a:r>
-              <a:rPr lang="es-CL" sz="2400" dirty="0">
-                <a:solidFill>
-                  <a:srgbClr val="1F2937"/>
-                </a:solidFill>
-              </a:rPr>
-              <a:t>Registro de pedidos y formularios; avisos y notificaciones; sincronizar planillas, CRM y bases de datos; reportes periódicos; clasificación de solicitudes; incorporación de clientes.</a:t>
+              <a:rPr lang="es-CL" sz="2000" dirty="0">
+                <a:solidFill>
+                  <a:srgbClr val="1F2937"/>
+                </a:solidFill>
+              </a:rPr>
+              <a:t>Tareas </a:t>
+            </a:r>
+            <a:r>
+              <a:rPr lang="es-CL" sz="2000" b="1" dirty="0">
+                <a:solidFill>
+                  <a:srgbClr val="1F2937"/>
+                </a:solidFill>
+              </a:rPr>
+              <a:t>repetitivas</a:t>
+            </a:r>
+            <a:r>
+              <a:rPr lang="es-CL" sz="2000" dirty="0">
+                <a:solidFill>
+                  <a:srgbClr val="1F2937"/>
+                </a:solidFill>
+              </a:rPr>
+              <a:t>, de </a:t>
+            </a:r>
+            <a:r>
+              <a:rPr lang="es-CL" sz="2000" b="1" dirty="0">
+                <a:solidFill>
+                  <a:srgbClr val="1F2937"/>
+                </a:solidFill>
+              </a:rPr>
+              <a:t>alto volumen</a:t>
+            </a:r>
+            <a:r>
+              <a:rPr lang="es-CL" sz="2000" dirty="0">
+                <a:solidFill>
+                  <a:srgbClr val="1F2937"/>
+                </a:solidFill>
+              </a:rPr>
+              <a:t>, con </a:t>
+            </a:r>
+            <a:r>
+              <a:rPr lang="es-CL" sz="2000" b="1" dirty="0">
+                <a:solidFill>
+                  <a:srgbClr val="1F2937"/>
+                </a:solidFill>
+              </a:rPr>
+              <a:t>reglas claras</a:t>
+            </a:r>
+            <a:r>
+              <a:rPr lang="es-CL" sz="2000" dirty="0">
+                <a:solidFill>
+                  <a:srgbClr val="1F2937"/>
+                </a:solidFill>
+              </a:rPr>
+              <a:t> y datos digitales.</a:t>
+            </a:r>
+          </a:p>
+          <a:p>
+            <a:pPr marL="342900" indent="-342900">
+              <a:spcBef>
+                <a:spcPts val="900"/>
+              </a:spcBef>
+              <a:buClr>
+                <a:srgbClr val="0E7490"/>
+              </a:buClr>
+              <a:buFont typeface="Arial"/>
+              <a:buChar char="•"/>
+            </a:pPr>
+            <a:r>
+              <a:rPr lang="es-CL" sz="2000" dirty="0">
+                <a:solidFill>
+                  <a:srgbClr val="1F2937"/>
+                </a:solidFill>
+              </a:rPr>
+              <a:t>Lo que no conviene: decisiones de criterio, tareas que ocurren una vez al año, procesos que todavía no están definidos.</a:t>
             </a:r>
           </a:p>
         </p:txBody>
@@ -1769,7 +2341,7 @@
                   <a:srgbClr val="6B7280"/>
                 </a:solidFill>
               </a:rPr>
-              <a:t>PF1821 · Módulo 2 · Cápsula 1 · AE1</a:t>
+              <a:t>PF1821 · Módulo 2 · Cápsula 1 · Aprendizaje esperado 1</a:t>
             </a:r>
           </a:p>
         </p:txBody>
@@ -1823,14 +2395,57 @@
       </p:sp>
       <p:sp>
         <p:nvSpPr>
+          <p:cNvPr id="7" name="Etiqueta"/>
+          <p:cNvSpPr txBox="1"/>
+          <p:nvPr/>
+        </p:nvSpPr>
+        <p:spPr>
+          <a:xfrm>
+            <a:off x="609600" y="228600"/>
+            <a:ext cx="7315200" cy="914400"/>
+          </a:xfrm>
+          <a:prstGeom prst="rect">
+            <a:avLst/>
+          </a:prstGeom>
+          <a:noFill/>
+        </p:spPr>
+        <p:txBody>
+          <a:bodyPr wrap="square" lIns="0" rIns="0" anchor="b">
+            <a:normAutofit/>
+          </a:bodyPr>
+          <a:lstStyle/>
+          <a:p>
+            <a:r>
+              <a:rPr lang="es-CL" sz="1200" b="1" dirty="0">
+                <a:solidFill>
+                  <a:srgbClr val="0E7490"/>
+                </a:solidFill>
+              </a:rPr>
+              <a:t>CONTENIDO DEL PLAN (TEXTUAL)</a:t>
+            </a:r>
+          </a:p>
+          <a:p>
+            <a:r>
+              <a:rPr lang="es-CL" sz="1200" b="1" dirty="0">
+                <a:solidFill>
+                  <a:srgbClr val="0F3D5E"/>
+                </a:solidFill>
+              </a:rPr>
+              <a:t>CASOS DE USO EMPRESARIALES.</a:t>
+            </a:r>
+          </a:p>
+        </p:txBody>
+      </p:sp>
+      <p:sp>
+        <p:nvSpPr>
           <p:cNvPr id="3" name="Título"/>
           <p:cNvSpPr txBox="1"/>
           <p:nvPr/>
         </p:nvSpPr>
         <p:spPr>
           <a:xfrm>
-            <a:off x="609600" y="381000"/>
-            <a:ext cx="7315200" cy="990600"/>
+            <a:off x="609600" y="1181100"/>
+            <a:ext cx="7315200" cy="685800"/>
           </a:xfrm>
           <a:prstGeom prst="rect">
             <a:avLst/>
@@ -1844,12 +2459,12 @@
           <a:lstStyle/>
           <a:p>
             <a:r>
-              <a:rPr lang="es-CL" sz="3200" b="1" dirty="0">
+              <a:rPr lang="es-CL" sz="2800" b="1" dirty="0">
                 <a:solidFill>
                   <a:srgbClr val="0F3D5E"/>
                 </a:solidFill>
               </a:rPr>
-              <a:t>Beneficios y retorno</a:t>
+              <a:t>Casos de uso empresariales</a:t>
             </a:r>
           </a:p>
         </p:txBody>
@@ -1862,7 +2477,7 @@
         </p:nvSpPr>
         <p:spPr>
           <a:xfrm>
-            <a:off x="609600" y="1447800"/>
+            <a:off x="609600" y="1943100"/>
             <a:ext cx="1066800" cy="50800"/>
           </a:xfrm>
           <a:prstGeom prst="rect">
@@ -1884,8 +2499,8 @@
         </p:nvSpPr>
         <p:spPr>
           <a:xfrm>
-            <a:off x="609600" y="1676400"/>
-            <a:ext cx="7315200" cy="4419600"/>
+            <a:off x="609600" y="2095500"/>
+            <a:ext cx="7315200" cy="4000500"/>
           </a:xfrm>
           <a:prstGeom prst="rect">
             <a:avLst/>
@@ -1909,52 +2524,12 @@
               <a:buChar char="•"/>
             </a:pPr>
             <a:r>
-              <a:rPr lang="es-CL" sz="2000" dirty="0">
-                <a:solidFill>
-                  <a:srgbClr val="1F2937"/>
-                </a:solidFill>
-              </a:rPr>
-              <a:t>Menos digitación y errores, respuesta inmediata, datos disponibles para decidir.</a:t>
-            </a:r>
-          </a:p>
-          <a:p>
-            <a:pPr marL="342900" indent="-342900">
-              <a:spcBef>
-                <a:spcPts val="900"/>
-              </a:spcBef>
-              <a:buClr>
-                <a:srgbClr val="0E7490"/>
-              </a:buClr>
-              <a:buFont typeface="Arial"/>
-              <a:buChar char="•"/>
-            </a:pPr>
-            <a:r>
-              <a:rPr lang="es-CL" sz="2000" dirty="0">
-                <a:solidFill>
-                  <a:srgbClr val="1F2937"/>
-                </a:solidFill>
-              </a:rPr>
-              <a:t>Cálculo simple: 40 pedidos al día × 3 minutos = 2 h diarias ≈ 40 h al mes que se liberan.</a:t>
-            </a:r>
-          </a:p>
-          <a:p>
-            <a:pPr marL="342900" indent="-342900">
-              <a:spcBef>
-                <a:spcPts val="900"/>
-              </a:spcBef>
-              <a:buClr>
-                <a:srgbClr val="0E7490"/>
-              </a:buClr>
-              <a:buFont typeface="Arial"/>
-              <a:buChar char="•"/>
-            </a:pPr>
-            <a:r>
-              <a:rPr lang="es-CL" sz="2000" dirty="0">
-                <a:solidFill>
-                  <a:srgbClr val="1F2937"/>
-                </a:solidFill>
-              </a:rPr>
-              <a:t>Retorno = valor de las horas liberadas − costo de la herramienta.</a:t>
+              <a:rPr lang="es-CL" sz="2400" dirty="0">
+                <a:solidFill>
+                  <a:srgbClr val="1F2937"/>
+                </a:solidFill>
+              </a:rPr>
+              <a:t>Registro de pedidos y formularios; avisos y notificaciones; sincronizar planillas, CRM y bases de datos; reportes periódicos; clasificación de solicitudes; incorporación de clientes.</a:t>
             </a:r>
           </a:p>
         </p:txBody>
@@ -1987,7 +2562,7 @@
                   <a:srgbClr val="6B7280"/>
                 </a:solidFill>
               </a:rPr>
-              <a:t>PF1821 · Módulo 2 · Cápsula 1 · AE1</a:t>
+              <a:t>PF1821 · Módulo 2 · Cápsula 1 · Aprendizaje esperado 1</a:t>
             </a:r>
           </a:p>
         </p:txBody>
@@ -2041,14 +2616,57 @@
       </p:sp>
       <p:sp>
         <p:nvSpPr>
+          <p:cNvPr id="7" name="Etiqueta"/>
+          <p:cNvSpPr txBox="1"/>
+          <p:nvPr/>
+        </p:nvSpPr>
+        <p:spPr>
+          <a:xfrm>
+            <a:off x="609600" y="228600"/>
+            <a:ext cx="7315200" cy="914400"/>
+          </a:xfrm>
+          <a:prstGeom prst="rect">
+            <a:avLst/>
+          </a:prstGeom>
+          <a:noFill/>
+        </p:spPr>
+        <p:txBody>
+          <a:bodyPr wrap="square" lIns="0" rIns="0" anchor="b">
+            <a:normAutofit/>
+          </a:bodyPr>
+          <a:lstStyle/>
+          <a:p>
+            <a:r>
+              <a:rPr lang="es-CL" sz="1200" b="1" dirty="0">
+                <a:solidFill>
+                  <a:srgbClr val="0E7490"/>
+                </a:solidFill>
+              </a:rPr>
+              <a:t>CONTENIDO DEL PLAN (TEXTUAL)</a:t>
+            </a:r>
+          </a:p>
+          <a:p>
+            <a:r>
+              <a:rPr lang="es-CL" sz="1200" b="1" dirty="0">
+                <a:solidFill>
+                  <a:srgbClr val="0F3D5E"/>
+                </a:solidFill>
+              </a:rPr>
+              <a:t>BENEFICIOS Y ROI DE LA AUTOMATIZACIÓN.</a:t>
+            </a:r>
+          </a:p>
+        </p:txBody>
+      </p:sp>
+      <p:sp>
+        <p:nvSpPr>
           <p:cNvPr id="3" name="Título"/>
           <p:cNvSpPr txBox="1"/>
           <p:nvPr/>
         </p:nvSpPr>
         <p:spPr>
           <a:xfrm>
-            <a:off x="609600" y="381000"/>
-            <a:ext cx="7315200" cy="990600"/>
+            <a:off x="609600" y="1181100"/>
+            <a:ext cx="7315200" cy="685800"/>
           </a:xfrm>
           <a:prstGeom prst="rect">
             <a:avLst/>
@@ -2062,12 +2680,12 @@
           <a:lstStyle/>
           <a:p>
             <a:r>
-              <a:rPr lang="es-CL" sz="3200" b="1" dirty="0">
+              <a:rPr lang="es-CL" sz="2800" b="1" dirty="0">
                 <a:solidFill>
                   <a:srgbClr val="0F3D5E"/>
                 </a:solidFill>
               </a:rPr>
-              <a:t>Arquitectura de n8n</a:t>
+              <a:t>Beneficios y retorno</a:t>
             </a:r>
           </a:p>
         </p:txBody>
@@ -2080,7 +2698,7 @@
         </p:nvSpPr>
         <p:spPr>
           <a:xfrm>
-            <a:off x="609600" y="1447800"/>
+            <a:off x="609600" y="1943100"/>
             <a:ext cx="1066800" cy="50800"/>
           </a:xfrm>
           <a:prstGeom prst="rect">
@@ -2102,8 +2720,8 @@
         </p:nvSpPr>
         <p:spPr>
           <a:xfrm>
-            <a:off x="609600" y="1676400"/>
-            <a:ext cx="7315200" cy="4419600"/>
+            <a:off x="609600" y="2095500"/>
+            <a:ext cx="7315200" cy="4000500"/>
           </a:xfrm>
           <a:prstGeom prst="rect">
             <a:avLst/>
@@ -2127,84 +2745,12 @@
               <a:buChar char="•"/>
             </a:pPr>
             <a:r>
-              <a:rPr lang="es-CL" sz="2000" b="1" dirty="0">
-                <a:solidFill>
-                  <a:srgbClr val="1F2937"/>
-                </a:solidFill>
-              </a:rPr>
-              <a:t>Workflow</a:t>
-            </a:r>
-            <a:r>
               <a:rPr lang="es-CL" sz="2000" dirty="0">
                 <a:solidFill>
                   <a:srgbClr val="1F2937"/>
                 </a:solidFill>
               </a:rPr>
-              <a:t> (el flujo completo) · </a:t>
-            </a:r>
-            <a:r>
-              <a:rPr lang="es-CL" sz="2000" b="1" dirty="0">
-                <a:solidFill>
-                  <a:srgbClr val="1F2937"/>
-                </a:solidFill>
-              </a:rPr>
-              <a:t>nodos</a:t>
-            </a:r>
-            <a:r>
-              <a:rPr lang="es-CL" sz="2000" dirty="0">
-                <a:solidFill>
-                  <a:srgbClr val="1F2937"/>
-                </a:solidFill>
-              </a:rPr>
-              <a:t> (cada paso: trigger, acción, lógica, transformación) · </a:t>
-            </a:r>
-            <a:r>
-              <a:rPr lang="es-CL" sz="2000" b="1" dirty="0">
-                <a:solidFill>
-                  <a:srgbClr val="1F2937"/>
-                </a:solidFill>
-              </a:rPr>
-              <a:t>conexiones</a:t>
-            </a:r>
-            <a:r>
-              <a:rPr lang="es-CL" sz="2000" dirty="0">
-                <a:solidFill>
-                  <a:srgbClr val="1F2937"/>
-                </a:solidFill>
-              </a:rPr>
-              <a:t> · </a:t>
-            </a:r>
-            <a:r>
-              <a:rPr lang="es-CL" sz="2000" b="1" dirty="0">
-                <a:solidFill>
-                  <a:srgbClr val="1F2937"/>
-                </a:solidFill>
-              </a:rPr>
-              <a:t>credenciales</a:t>
-            </a:r>
-            <a:r>
-              <a:rPr lang="es-CL" sz="2000" dirty="0">
-                <a:solidFill>
-                  <a:srgbClr val="1F2937"/>
-                </a:solidFill>
-              </a:rPr>
-              <a:t> (acceso seguro a otros servicios) · </a:t>
-            </a:r>
-            <a:r>
-              <a:rPr lang="es-CL" sz="2000" b="1" dirty="0">
-                <a:solidFill>
-                  <a:srgbClr val="1F2937"/>
-                </a:solidFill>
-              </a:rPr>
-              <a:t>ejecuciones</a:t>
-            </a:r>
-            <a:r>
-              <a:rPr lang="es-CL" sz="2000" dirty="0">
-                <a:solidFill>
-                  <a:srgbClr val="1F2937"/>
-                </a:solidFill>
-              </a:rPr>
-              <a:t> (cada vez que corre, con sus datos).</a:t>
+              <a:t>Menos digitación y errores, respuesta inmediata, datos disponibles para decidir.</a:t>
             </a:r>
           </a:p>
           <a:p>
@@ -2224,23 +2770,27 @@
                   <a:srgbClr val="1F2937"/>
                 </a:solidFill>
               </a:rPr>
-              <a:t>Los datos viajan como </a:t>
-            </a:r>
-            <a:r>
-              <a:rPr lang="es-CL" sz="2000" b="1" dirty="0">
-                <a:solidFill>
-                  <a:srgbClr val="1F2937"/>
-                </a:solidFill>
-              </a:rPr>
-              <a:t>ítems</a:t>
-            </a:r>
+              <a:t>Cálculo simple: 40 pedidos al día × 3 minutos = 2 h diarias ≈ 40 h al mes que se liberan.</a:t>
+            </a:r>
+          </a:p>
+          <a:p>
+            <a:pPr marL="342900" indent="-342900">
+              <a:spcBef>
+                <a:spcPts val="900"/>
+              </a:spcBef>
+              <a:buClr>
+                <a:srgbClr val="0E7490"/>
+              </a:buClr>
+              <a:buFont typeface="Arial"/>
+              <a:buChar char="•"/>
+            </a:pPr>
             <a:r>
               <a:rPr lang="es-CL" sz="2000" dirty="0">
                 <a:solidFill>
                   <a:srgbClr val="1F2937"/>
                 </a:solidFill>
               </a:rPr>
-              <a:t> en formato JSON.</a:t>
+              <a:t>Retorno = valor de las horas liberadas − costo de la herramienta.</a:t>
             </a:r>
           </a:p>
         </p:txBody>
@@ -2273,7 +2823,7 @@
                   <a:srgbClr val="6B7280"/>
                 </a:solidFill>
               </a:rPr>
-              <a:t>PF1821 · Módulo 2 · Cápsula 1 · AE1</a:t>
+              <a:t>PF1821 · Módulo 2 · Cápsula 1 · Aprendizaje esperado 1</a:t>
             </a:r>
           </a:p>
         </p:txBody>
@@ -2327,14 +2877,57 @@
       </p:sp>
       <p:sp>
         <p:nvSpPr>
+          <p:cNvPr id="7" name="Etiqueta"/>
+          <p:cNvSpPr txBox="1"/>
+          <p:nvPr/>
+        </p:nvSpPr>
+        <p:spPr>
+          <a:xfrm>
+            <a:off x="609600" y="228600"/>
+            <a:ext cx="7315200" cy="914400"/>
+          </a:xfrm>
+          <a:prstGeom prst="rect">
+            <a:avLst/>
+          </a:prstGeom>
+          <a:noFill/>
+        </p:spPr>
+        <p:txBody>
+          <a:bodyPr wrap="square" lIns="0" rIns="0" anchor="b">
+            <a:normAutofit/>
+          </a:bodyPr>
+          <a:lstStyle/>
+          <a:p>
+            <a:r>
+              <a:rPr lang="es-CL" sz="1200" b="1" dirty="0">
+                <a:solidFill>
+                  <a:srgbClr val="0E7490"/>
+                </a:solidFill>
+              </a:rPr>
+              <a:t>CONTENIDO DEL PLAN (TEXTUAL)</a:t>
+            </a:r>
+          </a:p>
+          <a:p>
+            <a:r>
+              <a:rPr lang="es-CL" sz="1200" b="1" dirty="0">
+                <a:solidFill>
+                  <a:srgbClr val="0F3D5E"/>
+                </a:solidFill>
+              </a:rPr>
+              <a:t>ARQUITECTURA DE N8N.</a:t>
+            </a:r>
+          </a:p>
+        </p:txBody>
+      </p:sp>
+      <p:sp>
+        <p:nvSpPr>
           <p:cNvPr id="3" name="Título"/>
           <p:cNvSpPr txBox="1"/>
           <p:nvPr/>
         </p:nvSpPr>
         <p:spPr>
           <a:xfrm>
-            <a:off x="609600" y="381000"/>
-            <a:ext cx="7315200" cy="990600"/>
+            <a:off x="609600" y="1181100"/>
+            <a:ext cx="7315200" cy="685800"/>
           </a:xfrm>
           <a:prstGeom prst="rect">
             <a:avLst/>
@@ -2348,12 +2941,12 @@
           <a:lstStyle/>
           <a:p>
             <a:r>
-              <a:rPr lang="es-CL" sz="3200" b="1" dirty="0">
+              <a:rPr lang="es-CL" sz="2800" b="1" dirty="0">
                 <a:solidFill>
                   <a:srgbClr val="0F3D5E"/>
                 </a:solidFill>
               </a:rPr>
-              <a:t>Componentes de la interfaz</a:t>
+              <a:t>Arquitectura de n8n</a:t>
             </a:r>
           </a:p>
         </p:txBody>
@@ -2366,7 +2959,7 @@
         </p:nvSpPr>
         <p:spPr>
           <a:xfrm>
-            <a:off x="609600" y="1447800"/>
+            <a:off x="609600" y="1943100"/>
             <a:ext cx="1066800" cy="50800"/>
           </a:xfrm>
           <a:prstGeom prst="rect">
@@ -2388,8 +2981,8 @@
         </p:nvSpPr>
         <p:spPr>
           <a:xfrm>
-            <a:off x="609600" y="1676400"/>
-            <a:ext cx="7315200" cy="4419600"/>
+            <a:off x="609600" y="2095500"/>
+            <a:ext cx="7315200" cy="4000500"/>
           </a:xfrm>
           <a:prstGeom prst="rect">
             <a:avLst/>
@@ -2413,12 +3006,120 @@
               <a:buChar char="•"/>
             </a:pPr>
             <a:r>
-              <a:rPr lang="es-CL" sz="2400" dirty="0">
-                <a:solidFill>
-                  <a:srgbClr val="1F2937"/>
-                </a:solidFill>
-              </a:rPr>
-              <a:t>Canvas · panel de nodos · parámetros del nodo · paneles de entrada y salida · historial de ejecuciones.</a:t>
+              <a:rPr lang="es-CL" sz="2000" b="1" dirty="0">
+                <a:solidFill>
+                  <a:srgbClr val="1F2937"/>
+                </a:solidFill>
+              </a:rPr>
+              <a:t>Workflow</a:t>
+            </a:r>
+            <a:r>
+              <a:rPr lang="es-CL" sz="2000" dirty="0">
+                <a:solidFill>
+                  <a:srgbClr val="1F2937"/>
+                </a:solidFill>
+              </a:rPr>
+              <a:t> (el flujo completo) · </a:t>
+            </a:r>
+            <a:r>
+              <a:rPr lang="es-CL" sz="2000" b="1" dirty="0">
+                <a:solidFill>
+                  <a:srgbClr val="1F2937"/>
+                </a:solidFill>
+              </a:rPr>
+              <a:t>nodos</a:t>
+            </a:r>
+            <a:r>
+              <a:rPr lang="es-CL" sz="2000" dirty="0">
+                <a:solidFill>
+                  <a:srgbClr val="1F2937"/>
+                </a:solidFill>
+              </a:rPr>
+              <a:t> (cada paso: trigger, acción, lógica, transformación) · </a:t>
+            </a:r>
+            <a:r>
+              <a:rPr lang="es-CL" sz="2000" b="1" dirty="0">
+                <a:solidFill>
+                  <a:srgbClr val="1F2937"/>
+                </a:solidFill>
+              </a:rPr>
+              <a:t>conexiones</a:t>
+            </a:r>
+            <a:r>
+              <a:rPr lang="es-CL" sz="2000" dirty="0">
+                <a:solidFill>
+                  <a:srgbClr val="1F2937"/>
+                </a:solidFill>
+              </a:rPr>
+              <a:t> · </a:t>
+            </a:r>
+            <a:r>
+              <a:rPr lang="es-CL" sz="2000" b="1" dirty="0">
+                <a:solidFill>
+                  <a:srgbClr val="1F2937"/>
+                </a:solidFill>
+              </a:rPr>
+              <a:t>credenciales</a:t>
+            </a:r>
+            <a:r>
+              <a:rPr lang="es-CL" sz="2000" dirty="0">
+                <a:solidFill>
+                  <a:srgbClr val="1F2937"/>
+                </a:solidFill>
+              </a:rPr>
+              <a:t> (acceso seguro a otros servicios) · </a:t>
+            </a:r>
+            <a:r>
+              <a:rPr lang="es-CL" sz="2000" b="1" dirty="0">
+                <a:solidFill>
+                  <a:srgbClr val="1F2937"/>
+                </a:solidFill>
+              </a:rPr>
+              <a:t>ejecuciones</a:t>
+            </a:r>
+            <a:r>
+              <a:rPr lang="es-CL" sz="2000" dirty="0">
+                <a:solidFill>
+                  <a:srgbClr val="1F2937"/>
+                </a:solidFill>
+              </a:rPr>
+              <a:t> (cada vez que corre, con sus datos).</a:t>
+            </a:r>
+          </a:p>
+          <a:p>
+            <a:pPr marL="342900" indent="-342900">
+              <a:spcBef>
+                <a:spcPts val="900"/>
+              </a:spcBef>
+              <a:buClr>
+                <a:srgbClr val="0E7490"/>
+              </a:buClr>
+              <a:buFont typeface="Arial"/>
+              <a:buChar char="•"/>
+            </a:pPr>
+            <a:r>
+              <a:rPr lang="es-CL" sz="2000" dirty="0">
+                <a:solidFill>
+                  <a:srgbClr val="1F2937"/>
+                </a:solidFill>
+              </a:rPr>
+              <a:t>Los datos viajan como </a:t>
+            </a:r>
+            <a:r>
+              <a:rPr lang="es-CL" sz="2000" b="1" dirty="0">
+                <a:solidFill>
+                  <a:srgbClr val="1F2937"/>
+                </a:solidFill>
+              </a:rPr>
+              <a:t>ítems</a:t>
+            </a:r>
+            <a:r>
+              <a:rPr lang="es-CL" sz="2000" dirty="0">
+                <a:solidFill>
+                  <a:srgbClr val="1F2937"/>
+                </a:solidFill>
+              </a:rPr>
+              <a:t> en formato JSON.</a:t>
             </a:r>
           </a:p>
         </p:txBody>
@@ -2451,7 +3152,7 @@
                   <a:srgbClr val="6B7280"/>
                 </a:solidFill>
               </a:rPr>
-              <a:t>PF1821 · Módulo 2 · Cápsula 1 · AE1</a:t>
+              <a:t>PF1821 · Módulo 2 · Cápsula 1 · Aprendizaje esperado 1</a:t>
             </a:r>
           </a:p>
         </p:txBody>
@@ -2505,14 +3206,57 @@
       </p:sp>
       <p:sp>
         <p:nvSpPr>
+          <p:cNvPr id="7" name="Etiqueta"/>
+          <p:cNvSpPr txBox="1"/>
+          <p:nvPr/>
+        </p:nvSpPr>
+        <p:spPr>
+          <a:xfrm>
+            <a:off x="609600" y="228600"/>
+            <a:ext cx="7315200" cy="914400"/>
+          </a:xfrm>
+          <a:prstGeom prst="rect">
+            <a:avLst/>
+          </a:prstGeom>
+          <a:noFill/>
+        </p:spPr>
+        <p:txBody>
+          <a:bodyPr wrap="square" lIns="0" rIns="0" anchor="b">
+            <a:normAutofit/>
+          </a:bodyPr>
+          <a:lstStyle/>
+          <a:p>
+            <a:r>
+              <a:rPr lang="es-CL" sz="1200" b="1" dirty="0">
+                <a:solidFill>
+                  <a:srgbClr val="0E7490"/>
+                </a:solidFill>
+              </a:rPr>
+              <a:t>CONTENIDO DEL PLAN (TEXTUAL)</a:t>
+            </a:r>
+          </a:p>
+          <a:p>
+            <a:r>
+              <a:rPr lang="es-CL" sz="1200" b="1" dirty="0">
+                <a:solidFill>
+                  <a:srgbClr val="0F3D5E"/>
+                </a:solidFill>
+              </a:rPr>
+              <a:t>COMPONENTES PRINCIPALES.</a:t>
+            </a:r>
+          </a:p>
+        </p:txBody>
+      </p:sp>
+      <p:sp>
+        <p:nvSpPr>
           <p:cNvPr id="3" name="Título"/>
           <p:cNvSpPr txBox="1"/>
           <p:nvPr/>
         </p:nvSpPr>
         <p:spPr>
           <a:xfrm>
-            <a:off x="609600" y="381000"/>
-            <a:ext cx="7315200" cy="990600"/>
+            <a:off x="609600" y="1181100"/>
+            <a:ext cx="7315200" cy="685800"/>
           </a:xfrm>
           <a:prstGeom prst="rect">
             <a:avLst/>
@@ -2526,12 +3270,12 @@
           <a:lstStyle/>
           <a:p>
             <a:r>
-              <a:rPr lang="es-CL" sz="3200" b="1" dirty="0">
+              <a:rPr lang="es-CL" sz="2800" b="1" dirty="0">
                 <a:solidFill>
                   <a:srgbClr val="0F3D5E"/>
                 </a:solidFill>
               </a:rPr>
-              <a:t>Ecosistema de nodos</a:t>
+              <a:t>Componentes de la interfaz</a:t>
             </a:r>
           </a:p>
         </p:txBody>
@@ -2544,7 +3288,7 @@
         </p:nvSpPr>
         <p:spPr>
           <a:xfrm>
-            <a:off x="609600" y="1447800"/>
+            <a:off x="609600" y="1943100"/>
             <a:ext cx="1066800" cy="50800"/>
           </a:xfrm>
           <a:prstGeom prst="rect">
@@ -2566,8 +3310,8 @@
         </p:nvSpPr>
         <p:spPr>
           <a:xfrm>
-            <a:off x="609600" y="1676400"/>
-            <a:ext cx="7315200" cy="4419600"/>
+            <a:off x="609600" y="2095500"/>
+            <a:ext cx="7315200" cy="4000500"/>
           </a:xfrm>
           <a:prstGeom prst="rect">
             <a:avLst/>
@@ -2591,44 +3335,12 @@
               <a:buChar char="•"/>
             </a:pPr>
             <a:r>
-              <a:rPr lang="es-CL" sz="2000" dirty="0">
-                <a:solidFill>
-                  <a:srgbClr val="1F2937"/>
-                </a:solidFill>
-              </a:rPr>
-              <a:t>Nodos nativos para cientos de servicios (bases de datos, correo, planillas, mensajería), </a:t>
-            </a:r>
-            <a:r>
-              <a:rPr lang="es-CL" sz="2000" b="1" dirty="0">
-                <a:solidFill>
-                  <a:srgbClr val="1F2937"/>
-                </a:solidFill>
-              </a:rPr>
-              <a:t>HTTP Request</a:t>
-            </a:r>
-            <a:r>
-              <a:rPr lang="es-CL" sz="2000" dirty="0">
-                <a:solidFill>
-                  <a:srgbClr val="1F2937"/>
-                </a:solidFill>
-              </a:rPr>
-              <a:t> para cualquier API, </a:t>
-            </a:r>
-            <a:r>
-              <a:rPr lang="es-CL" sz="2000" b="1" dirty="0">
-                <a:solidFill>
-                  <a:srgbClr val="1F2937"/>
-                </a:solidFill>
-              </a:rPr>
-              <a:t>Code</a:t>
-            </a:r>
-            <a:r>
-              <a:rPr lang="es-CL" sz="2000" dirty="0">
-                <a:solidFill>
-                  <a:srgbClr val="1F2937"/>
-                </a:solidFill>
-              </a:rPr>
-              <a:t> para lógica propia, nodos de IA (se ven en el módulo 5 del plan) y nodos de la comunidad.</a:t>
+              <a:rPr lang="es-CL" sz="2400" dirty="0">
+                <a:solidFill>
+                  <a:srgbClr val="1F2937"/>
+                </a:solidFill>
+              </a:rPr>
+              <a:t>Canvas · panel de nodos · parámetros del nodo · paneles de entrada y salida · historial de ejecuciones.</a:t>
             </a:r>
           </a:p>
         </p:txBody>
@@ -2661,7 +3373,7 @@
                   <a:srgbClr val="6B7280"/>
                 </a:solidFill>
               </a:rPr>
-              <a:t>PF1821 · Módulo 2 · Cápsula 1 · AE1</a:t>
+              <a:t>PF1821 · Módulo 2 · Cápsula 1 · Aprendizaje esperado 1</a:t>
             </a:r>
           </a:p>
         </p:txBody>
@@ -2715,14 +3427,57 @@
       </p:sp>
       <p:sp>
         <p:nvSpPr>
+          <p:cNvPr id="7" name="Etiqueta"/>
+          <p:cNvSpPr txBox="1"/>
+          <p:nvPr/>
+        </p:nvSpPr>
+        <p:spPr>
+          <a:xfrm>
+            <a:off x="609600" y="228600"/>
+            <a:ext cx="7315200" cy="914400"/>
+          </a:xfrm>
+          <a:prstGeom prst="rect">
+            <a:avLst/>
+          </a:prstGeom>
+          <a:noFill/>
+        </p:spPr>
+        <p:txBody>
+          <a:bodyPr wrap="square" lIns="0" rIns="0" anchor="b">
+            <a:normAutofit/>
+          </a:bodyPr>
+          <a:lstStyle/>
+          <a:p>
+            <a:r>
+              <a:rPr lang="es-CL" sz="1200" b="1" dirty="0">
+                <a:solidFill>
+                  <a:srgbClr val="0E7490"/>
+                </a:solidFill>
+              </a:rPr>
+              <a:t>CONTENIDO DEL PLAN (TEXTUAL)</a:t>
+            </a:r>
+          </a:p>
+          <a:p>
+            <a:r>
+              <a:rPr lang="es-CL" sz="1200" b="1" dirty="0">
+                <a:solidFill>
+                  <a:srgbClr val="0F3D5E"/>
+                </a:solidFill>
+              </a:rPr>
+              <a:t>ECOSISTEMA DE NODOS.</a:t>
+            </a:r>
+          </a:p>
+        </p:txBody>
+      </p:sp>
+      <p:sp>
+        <p:nvSpPr>
           <p:cNvPr id="3" name="Título"/>
           <p:cNvSpPr txBox="1"/>
           <p:nvPr/>
         </p:nvSpPr>
         <p:spPr>
           <a:xfrm>
-            <a:off x="609600" y="381000"/>
-            <a:ext cx="7315200" cy="990600"/>
+            <a:off x="609600" y="1181100"/>
+            <a:ext cx="7315200" cy="685800"/>
           </a:xfrm>
           <a:prstGeom prst="rect">
             <a:avLst/>
@@ -2736,12 +3491,12 @@
           <a:lstStyle/>
           <a:p>
             <a:r>
-              <a:rPr lang="es-CL" sz="3200" b="1" dirty="0">
+              <a:rPr lang="es-CL" sz="2800" b="1" dirty="0">
                 <a:solidFill>
                   <a:srgbClr val="0F3D5E"/>
                 </a:solidFill>
               </a:rPr>
-              <a:t>n8n frente a otras plataformas</a:t>
+              <a:t>Ecosistema de nodos</a:t>
             </a:r>
           </a:p>
         </p:txBody>
@@ -2754,7 +3509,7 @@
         </p:nvSpPr>
         <p:spPr>
           <a:xfrm>
-            <a:off x="609600" y="1447800"/>
+            <a:off x="609600" y="1943100"/>
             <a:ext cx="1066800" cy="50800"/>
           </a:xfrm>
           <a:prstGeom prst="rect">
@@ -2776,8 +3531,8 @@
         </p:nvSpPr>
         <p:spPr>
           <a:xfrm>
-            <a:off x="609600" y="1676400"/>
-            <a:ext cx="7315200" cy="4419600"/>
+            <a:off x="609600" y="2095500"/>
+            <a:ext cx="7315200" cy="4000500"/>
           </a:xfrm>
           <a:prstGeom prst="rect">
             <a:avLst/>
@@ -2801,32 +3556,44 @@
               <a:buChar char="•"/>
             </a:pPr>
             <a:r>
-              <a:rPr lang="es-CL" sz="2400" dirty="0">
-                <a:solidFill>
-                  <a:srgbClr val="1F2937"/>
-                </a:solidFill>
-              </a:rPr>
-              <a:t>Ver el cuadro comparativo R04.</a:t>
-            </a:r>
-          </a:p>
-          <a:p>
-            <a:pPr marL="342900" indent="-342900">
-              <a:spcBef>
-                <a:spcPts val="900"/>
-              </a:spcBef>
-              <a:buClr>
-                <a:srgbClr val="0E7490"/>
-              </a:buClr>
-              <a:buFont typeface="Arial"/>
-              <a:buChar char="•"/>
-            </a:pPr>
-            <a:r>
-              <a:rPr lang="es-CL" sz="2400" dirty="0">
-                <a:solidFill>
-                  <a:srgbClr val="1F2937"/>
-                </a:solidFill>
-              </a:rPr>
-              <a:t>Idea central: n8n puede instalarse en infraestructura propia, lo que da control sobre los datos.</a:t>
+              <a:rPr lang="es-CL" sz="2000" dirty="0">
+                <a:solidFill>
+                  <a:srgbClr val="1F2937"/>
+                </a:solidFill>
+              </a:rPr>
+              <a:t>Nodos nativos para cientos de servicios (bases de datos, correo, planillas, mensajería), </a:t>
+            </a:r>
+            <a:r>
+              <a:rPr lang="es-CL" sz="2000" b="1" dirty="0">
+                <a:solidFill>
+                  <a:srgbClr val="1F2937"/>
+                </a:solidFill>
+              </a:rPr>
+              <a:t>HTTP Request</a:t>
+            </a:r>
+            <a:r>
+              <a:rPr lang="es-CL" sz="2000" dirty="0">
+                <a:solidFill>
+                  <a:srgbClr val="1F2937"/>
+                </a:solidFill>
+              </a:rPr>
+              <a:t> para cualquier API, </a:t>
+            </a:r>
+            <a:r>
+              <a:rPr lang="es-CL" sz="2000" b="1" dirty="0">
+                <a:solidFill>
+                  <a:srgbClr val="1F2937"/>
+                </a:solidFill>
+              </a:rPr>
+              <a:t>Code</a:t>
+            </a:r>
+            <a:r>
+              <a:rPr lang="es-CL" sz="2000" dirty="0">
+                <a:solidFill>
+                  <a:srgbClr val="1F2937"/>
+                </a:solidFill>
+              </a:rPr>
+              <a:t> para lógica propia, nodos de IA (se ven en el módulo 5 del plan) y nodos de la comunidad.</a:t>
             </a:r>
           </a:p>
         </p:txBody>
@@ -2859,7 +3626,7 @@
                   <a:srgbClr val="6B7280"/>
                 </a:solidFill>
               </a:rPr>
-              <a:t>PF1821 · Módulo 2 · Cápsula 1 · AE1</a:t>
+              <a:t>PF1821 · Módulo 2 · Cápsula 1 · Aprendizaje esperado 1</a:t>
             </a:r>
           </a:p>
         </p:txBody>

</xml_diff>